<commit_message>
docs: update team roles and contributors
Reflect updated team roles and member details in documentation and presentation assets.
</commit_message>
<xml_diff>
--- a/RegulaTrace_AI_Presentation_Accenture_Hackathon.pptx
+++ b/RegulaTrace_AI_Presentation_Accenture_Hackathon.pptx
@@ -1890,7 +1890,7 @@
                 <a:ea typeface="Arial" pitchFamily="34" charset="-122"/>
                 <a:cs typeface="Arial" pitchFamily="34" charset="-120"/>
               </a:rPr>
-              <a:t>Nifasath Farhana K</a:t>
+              <a:t>Nagarajan R</a:t>
             </a:r>
             <a:endParaRPr lang="en-US" sz="1400" dirty="0"/>
           </a:p>
@@ -1929,7 +1929,7 @@
                 <a:ea typeface="Arial" pitchFamily="34" charset="-122"/>
                 <a:cs typeface="Arial" pitchFamily="34" charset="-120"/>
               </a:rPr>
-              <a:t>Lead AI Engineer &amp; Full-Stack Architect</a:t>
+              <a:t>Lead Full-Stack Architect &amp; Systems Engineer</a:t>
             </a:r>
             <a:endParaRPr lang="en-US" sz="1100" dirty="0"/>
           </a:p>
@@ -1946,7 +1946,7 @@
                 <a:ea typeface="Arial" pitchFamily="34" charset="-122"/>
                 <a:cs typeface="Arial" pitchFamily="34" charset="-120"/>
               </a:rPr>
-              <a:t>Agentic Workflow &amp; Ingestion Pipeline</a:t>
+              <a:t>Compliance Systems Architecture &amp; Integration</a:t>
             </a:r>
             <a:endParaRPr lang="en-US" sz="1100" dirty="0"/>
           </a:p>
@@ -2010,7 +2010,7 @@
                 <a:ea typeface="Arial" pitchFamily="34" charset="-122"/>
                 <a:cs typeface="Arial" pitchFamily="34" charset="-120"/>
               </a:rPr>
-              <a:t>Subraja S</a:t>
+              <a:t>Nifasath Farhana K</a:t>
             </a:r>
             <a:endParaRPr lang="en-US" sz="1400" dirty="0"/>
           </a:p>
@@ -2049,7 +2049,7 @@
                 <a:ea typeface="Arial" pitchFamily="34" charset="-122"/>
                 <a:cs typeface="Arial" pitchFamily="34" charset="-120"/>
               </a:rPr>
-              <a:t>Compliance Systems &amp; Domain Engineer</a:t>
+              <a:t>Lead AI Engineer &amp; Agentic Systems Architect</a:t>
             </a:r>
             <a:endParaRPr lang="en-US" sz="1100" dirty="0"/>
           </a:p>
@@ -2066,7 +2066,7 @@
                 <a:ea typeface="Arial" pitchFamily="34" charset="-122"/>
                 <a:cs typeface="Arial" pitchFamily="34" charset="-120"/>
               </a:rPr>
-              <a:t>Banking Controls &amp; 3LoD Governance</a:t>
+              <a:t>Gemini 1.5 Ingestion &amp; Deterministic Match Engine</a:t>
             </a:r>
             <a:endParaRPr lang="en-US" sz="1100" dirty="0"/>
           </a:p>
@@ -2217,7 +2217,7 @@
                 <a:ea typeface="Arial" pitchFamily="34" charset="-122"/>
                 <a:cs typeface="Arial" pitchFamily="34" charset="-120"/>
               </a:rPr>
-              <a:t>Track: Agentic AI in Enterprise &amp; Banking  |  Model: Google Gemini 1.5 Flash  |  29/29 Acceptance Tests Passed</a:t>
+              <a:t>Team: Nagarajan R &amp; Nifasath Farhana K  |  Track: Agentic AI in Enterprise &amp; Banking  |  29/29 Tests Passed</a:t>
             </a:r>
             <a:endParaRPr lang="en-US" sz="1100" dirty="0"/>
           </a:p>
@@ -3124,7 +3124,7 @@
                 <a:ea typeface="Arial" pitchFamily="34" charset="-122"/>
                 <a:cs typeface="Arial" pitchFamily="34" charset="-120"/>
               </a:rPr>
-              <a:t>GitHub: https://github.com/nifasathfarhanak/accenture_hackathon  |  Accenture Hackathon  |  Thank You!</a:t>
+              <a:t>Team: Nagarajan R &amp; Nifasath Farhana K  |  GitHub: https://github.com/nifasathfarhanak/accenture_hackathon  |  Thank You!</a:t>
             </a:r>
             <a:endParaRPr lang="en-US" sz="1100" dirty="0"/>
           </a:p>

</xml_diff>